<commit_message>
fix: correct image aspect ratios in all slides
- corona_map_road_*.png: 4.6x3.68 → 3.1x4.3 (AR 0.717, portrait)
- corona_road_type_map.png: 7.6x4.4 → 3.61x4.5, centered (AR 0.802)
- corona_always_trend.png: 5.6x4.65 → 3.58x4.65 (AR 0.769)
- map_price.png: 4.0x4.75 → 4.0x4.16 (AR 0.962)
- shap_covid_shock.png: 5.7x3.99 → 4.56x4.2 (AR 1.086)

Co-Authored-By: Claude Sonnet 4.6 <noreply@anthropic.com>
</commit_message>
<xml_diff>
--- a/outputs/PBL発表_v2.pptx
+++ b/outputs/PBL発表_v2.pptx
@@ -2519,7 +2519,7 @@
         <p:spPr>
           <a:xfrm>
             <a:off x="109728" y="749808"/>
-            <a:ext cx="5212080" cy="3648456"/>
+            <a:ext cx="4169664" cy="3840480"/>
           </a:xfrm>
           <a:prstGeom prst="rect">
             <a:avLst/>
@@ -3221,8 +3221,8 @@
         </p:blipFill>
         <p:spPr>
           <a:xfrm>
-            <a:off x="1097280" y="841248"/>
-            <a:ext cx="6949440" cy="4023360"/>
+            <a:off x="2926080" y="841248"/>
+            <a:ext cx="3300984" cy="4114800"/>
           </a:xfrm>
           <a:prstGeom prst="rect">
             <a:avLst/>
@@ -3356,7 +3356,7 @@
         <p:spPr>
           <a:xfrm>
             <a:off x="182880" y="777240"/>
-            <a:ext cx="5120640" cy="4251960"/>
+            <a:ext cx="3273552" cy="4251960"/>
           </a:xfrm>
           <a:prstGeom prst="rect">
             <a:avLst/>
@@ -7254,7 +7254,7 @@
         <p:spPr>
           <a:xfrm>
             <a:off x="5257800" y="566928"/>
-            <a:ext cx="3657600" cy="4343400"/>
+            <a:ext cx="3657600" cy="3803904"/>
           </a:xfrm>
           <a:prstGeom prst="rect">
             <a:avLst/>
@@ -7269,7 +7269,7 @@
         </p:nvSpPr>
         <p:spPr>
           <a:xfrm>
-            <a:off x="5257800" y="4846320"/>
+            <a:off x="5257800" y="4425696"/>
             <a:ext cx="3657600" cy="201168"/>
           </a:xfrm>
           <a:prstGeom prst="rect">
@@ -8469,8 +8469,8 @@
         </p:nvSpPr>
         <p:spPr>
           <a:xfrm>
-            <a:off x="137160" y="676656"/>
-            <a:ext cx="4206240" cy="201168"/>
+            <a:off x="1508760" y="676656"/>
+            <a:ext cx="2834640" cy="201168"/>
           </a:xfrm>
           <a:prstGeom prst="rect">
             <a:avLst/>
@@ -8516,8 +8516,8 @@
         </p:blipFill>
         <p:spPr>
           <a:xfrm>
-            <a:off x="137160" y="877824"/>
-            <a:ext cx="4206240" cy="3364992"/>
+            <a:off x="1508760" y="877824"/>
+            <a:ext cx="2834640" cy="3931920"/>
           </a:xfrm>
           <a:prstGeom prst="rect">
             <a:avLst/>
@@ -8533,7 +8533,7 @@
         <p:spPr>
           <a:xfrm>
             <a:off x="4800600" y="676656"/>
-            <a:ext cx="4206240" cy="201168"/>
+            <a:ext cx="2834640" cy="201168"/>
           </a:xfrm>
           <a:prstGeom prst="rect">
             <a:avLst/>
@@ -8580,7 +8580,7 @@
         <p:spPr>
           <a:xfrm>
             <a:off x="4800600" y="877824"/>
-            <a:ext cx="4206240" cy="3364992"/>
+            <a:ext cx="2834640" cy="3931920"/>
           </a:xfrm>
           <a:prstGeom prst="rect">
             <a:avLst/>
@@ -8744,8 +8744,8 @@
         </p:nvSpPr>
         <p:spPr>
           <a:xfrm>
-            <a:off x="137160" y="676656"/>
-            <a:ext cx="4206240" cy="201168"/>
+            <a:off x="1508760" y="676656"/>
+            <a:ext cx="2834640" cy="201168"/>
           </a:xfrm>
           <a:prstGeom prst="rect">
             <a:avLst/>
@@ -8791,8 +8791,8 @@
         </p:blipFill>
         <p:spPr>
           <a:xfrm>
-            <a:off x="137160" y="877824"/>
-            <a:ext cx="4206240" cy="3364992"/>
+            <a:off x="1508760" y="877824"/>
+            <a:ext cx="2834640" cy="3931920"/>
           </a:xfrm>
           <a:prstGeom prst="rect">
             <a:avLst/>
@@ -8808,7 +8808,7 @@
         <p:spPr>
           <a:xfrm>
             <a:off x="4800600" y="676656"/>
-            <a:ext cx="4206240" cy="201168"/>
+            <a:ext cx="2834640" cy="201168"/>
           </a:xfrm>
           <a:prstGeom prst="rect">
             <a:avLst/>
@@ -8855,7 +8855,7 @@
         <p:spPr>
           <a:xfrm>
             <a:off x="4800600" y="877824"/>
-            <a:ext cx="4206240" cy="3364992"/>
+            <a:ext cx="2834640" cy="3931920"/>
           </a:xfrm>
           <a:prstGeom prst="rect">
             <a:avLst/>
@@ -9019,8 +9019,8 @@
         </p:nvSpPr>
         <p:spPr>
           <a:xfrm>
-            <a:off x="137160" y="676656"/>
-            <a:ext cx="4206240" cy="201168"/>
+            <a:off x="1508760" y="676656"/>
+            <a:ext cx="2834640" cy="201168"/>
           </a:xfrm>
           <a:prstGeom prst="rect">
             <a:avLst/>
@@ -9066,8 +9066,8 @@
         </p:blipFill>
         <p:spPr>
           <a:xfrm>
-            <a:off x="137160" y="877824"/>
-            <a:ext cx="4206240" cy="3364992"/>
+            <a:off x="1508760" y="877824"/>
+            <a:ext cx="2834640" cy="3931920"/>
           </a:xfrm>
           <a:prstGeom prst="rect">
             <a:avLst/>
@@ -9083,7 +9083,7 @@
         <p:spPr>
           <a:xfrm>
             <a:off x="4800600" y="676656"/>
-            <a:ext cx="4206240" cy="201168"/>
+            <a:ext cx="2834640" cy="201168"/>
           </a:xfrm>
           <a:prstGeom prst="rect">
             <a:avLst/>
@@ -9130,7 +9130,7 @@
         <p:spPr>
           <a:xfrm>
             <a:off x="4800600" y="877824"/>
-            <a:ext cx="4206240" cy="3364992"/>
+            <a:ext cx="2834640" cy="3931920"/>
           </a:xfrm>
           <a:prstGeom prst="rect">
             <a:avLst/>
@@ -9908,7 +9908,7 @@
                 <a:ea typeface="Arial" pitchFamily="34" charset="-122"/>
                 <a:cs typeface="Arial" pitchFamily="34" charset="-120"/>
               </a:rPr>
-              <a:t>—%</a:t>
+              <a:t>7.1%</a:t>
             </a:r>
             <a:endParaRPr lang="en-US" sz="3000" dirty="0"/>
           </a:p>
@@ -9947,7 +9947,7 @@
                 <a:ea typeface="Arial" pitchFamily="34" charset="-122"/>
                 <a:cs typeface="Arial" pitchFamily="34" charset="-120"/>
               </a:rPr>
-              <a:t>—万件</a:t>
+              <a:t>16万件</a:t>
             </a:r>
             <a:endParaRPr lang="en-US" sz="1000" dirty="0"/>
           </a:p>
@@ -10173,7 +10173,7 @@
                 <a:ea typeface="Arial" pitchFamily="34" charset="-122"/>
                 <a:cs typeface="Arial" pitchFamily="34" charset="-120"/>
               </a:rPr>
-              <a:t>—%</a:t>
+              <a:t>60.5%</a:t>
             </a:r>
             <a:endParaRPr lang="en-US" sz="3000" dirty="0"/>
           </a:p>
@@ -10212,7 +10212,7 @@
                 <a:ea typeface="Arial" pitchFamily="34" charset="-122"/>
                 <a:cs typeface="Arial" pitchFamily="34" charset="-120"/>
               </a:rPr>
-              <a:t>—万件</a:t>
+              <a:t>140万件</a:t>
             </a:r>
             <a:endParaRPr lang="en-US" sz="1000" dirty="0"/>
           </a:p>
@@ -11169,7 +11169,7 @@
                 <a:ea typeface="Arial" pitchFamily="34" charset="-122"/>
                 <a:cs typeface="Arial" pitchFamily="34" charset="-120"/>
               </a:rPr>
-              <a:t>※ 構造的上昇・安定の割合はF1ノートブック実行後に更新 ｜ コロナ下落計 18.5%のうち回復は約3割</a:t>
+              <a:t>※ 全国 230万路線を分類（2018–2022年パネル）｜ コロナ下落計 23.3%（コロナ型12.5% + 構造的10.8%）のうち回復型は約3割</a:t>
             </a:r>
             <a:endParaRPr lang="en-US" sz="1100" dirty="0"/>
           </a:p>

</xml_diff>